<commit_message>
fix(deck): left-aligned titles, title slide spacing and text fixes from Google Slides QA
</commit_message>
<xml_diff>
--- a/deck/ETS_ML2_Presentasi.pptx
+++ b/deck/ETS_ML2_Presentasi.pptx
@@ -119,7 +119,7 @@
   <p:extLst>
     <p:ext uri="{521415D9-36F7-43E2-AB2F-B90AF26B5E84}">
       <p14:sectionLst xmlns:p14="http://schemas.microsoft.com/office/powerpoint/2010/main">
-        <p14:section name="Erlangga: latar belakang &amp; data" id="{9857f73a-f975-ca96-8cad-bde241105d0d}">
+        <p14:section name="Erlangga: latar belakang &amp; data" id="{20936aa1-e3e8-276c-49be-c6a1090c11d6}">
           <p14:sldIdLst>
             <p14:sldId id="256"/>
             <p14:sldId id="257"/>
@@ -128,14 +128,14 @@
             <p14:sldId id="260"/>
           </p14:sldIdLst>
         </p14:section>
-        <p14:section name="Michael: imbalance, augmentasi, ensemble" id="{0a4ef1df-c626-b7ff-c4c9-3657cbfd66da}">
+        <p14:section name="Michael: imbalance, augmentasi, ensemble" id="{d3cd5455-d0f4-bec5-585f-d0baee338a60}">
           <p14:sldIdLst>
             <p14:sldId id="261"/>
             <p14:sldId id="262"/>
             <p14:sldId id="263"/>
           </p14:sldIdLst>
         </p14:section>
-        <p14:section name="Rijal: reinforcement, diskusi, kesimpulan" id="{70fd3488-49fd-0c81-d44f-90984855a399}">
+        <p14:section name="Rijal: reinforcement, diskusi, kesimpulan" id="{93075c7e-966d-f5b7-f765-a204c37e9a67}">
           <p14:sldIdLst>
             <p14:sldId id="264"/>
             <p14:sldId id="265"/>
@@ -1802,7 +1802,7 @@
         <p:txBody>
           <a:bodyPr wrap="square" rtlCol="0"/>
           <a:lstStyle>
-            <a:lvl1pPr indent="0" marL="0">
+            <a:lvl1pPr algn="l" indent="0" marL="0">
               <a:buNone/>
               <a:defRPr lang="en-US" sz="3000" b="1" dirty="0">
                 <a:solidFill>
@@ -1815,7 +1815,7 @@
             </a:lvl1pPr>
           </a:lstStyle>
           <a:p>
-            <a:pPr indent="0" marL="0">
+            <a:pPr algn="l" indent="0" marL="0">
               <a:buNone/>
             </a:pPr>
             <a:endParaRPr lang="en-US" sz="3000" dirty="0"/>
@@ -2302,8 +2302,8 @@
         </p:nvSpPr>
         <p:spPr>
           <a:xfrm>
-            <a:off x="548640" y="1280160"/>
-            <a:ext cx="10607040" cy="1828800"/>
+            <a:off x="548640" y="1234440"/>
+            <a:ext cx="10607040" cy="2103120"/>
           </a:xfrm>
           <a:prstGeom prst="rect">
             <a:avLst/>
@@ -2319,7 +2319,7 @@
               <a:buNone/>
             </a:pPr>
             <a:r>
-              <a:rPr lang="en-US" sz="4400" b="1" dirty="0">
+              <a:rPr lang="en-US" sz="4000" b="1" dirty="0">
                 <a:solidFill>
                   <a:schemeClr val="bg1"/>
                 </a:solidFill>
@@ -2327,9 +2327,43 @@
                 <a:ea typeface="Cambria" pitchFamily="34" charset="-122"/>
                 <a:cs typeface="Cambria" pitchFamily="34" charset="-120"/>
               </a:rPr>
-              <a:t>Prediksi Kesegaran Daging dan Kelarutan Senyawa dengan Machine Learning</a:t>
-            </a:r>
-            <a:endParaRPr lang="en-US" sz="4400" dirty="0"/>
+              <a:t>Prediksi Kesegaran Daging dan</a:t>
+            </a:r>
+            <a:endParaRPr lang="en-US" sz="4000" dirty="0"/>
+          </a:p>
+          <a:p>
+            <a:pPr indent="0" marL="0">
+              <a:buNone/>
+            </a:pPr>
+            <a:r>
+              <a:rPr lang="en-US" sz="4000" b="1" dirty="0">
+                <a:solidFill>
+                  <a:schemeClr val="bg1"/>
+                </a:solidFill>
+                <a:latin typeface="Cambria" pitchFamily="34" charset="0"/>
+                <a:ea typeface="Cambria" pitchFamily="34" charset="-122"/>
+                <a:cs typeface="Cambria" pitchFamily="34" charset="-120"/>
+              </a:rPr>
+              <a:t>Kelarutan Senyawa</a:t>
+            </a:r>
+            <a:endParaRPr lang="en-US" sz="4000" dirty="0"/>
+          </a:p>
+          <a:p>
+            <a:pPr indent="0" marL="0">
+              <a:buNone/>
+            </a:pPr>
+            <a:r>
+              <a:rPr lang="en-US" sz="4000" b="1" dirty="0">
+                <a:solidFill>
+                  <a:schemeClr val="bg1"/>
+                </a:solidFill>
+                <a:latin typeface="Cambria" pitchFamily="34" charset="0"/>
+                <a:ea typeface="Cambria" pitchFamily="34" charset="-122"/>
+                <a:cs typeface="Cambria" pitchFamily="34" charset="-120"/>
+              </a:rPr>
+              <a:t>dengan Machine Learning</a:t>
+            </a:r>
+            <a:endParaRPr lang="en-US" sz="4000" dirty="0"/>
           </a:p>
         </p:txBody>
       </p:sp>
@@ -2341,31 +2375,31 @@
         </p:nvSpPr>
         <p:spPr>
           <a:xfrm>
-            <a:off x="548640" y="3200400"/>
-            <a:ext cx="9601200" cy="822960"/>
-          </a:xfrm>
-          <a:prstGeom prst="rect">
-            <a:avLst/>
-          </a:prstGeom>
-          <a:noFill/>
-          <a:ln/>
-        </p:spPr>
-        <p:txBody>
-          <a:bodyPr wrap="square" lIns="0" tIns="0" rIns="0" bIns="0" rtlCol="0" anchor="ctr"/>
-          <a:lstStyle/>
-          <a:p>
-            <a:pPr indent="0" marL="0">
-              <a:buNone/>
-            </a:pPr>
-            <a:r>
-              <a:rPr lang="en-US" sz="2000" dirty="0">
+            <a:off x="548640" y="3474720"/>
+            <a:ext cx="9601200" cy="731520"/>
+          </a:xfrm>
+          <a:prstGeom prst="rect">
+            <a:avLst/>
+          </a:prstGeom>
+          <a:noFill/>
+          <a:ln/>
+        </p:spPr>
+        <p:txBody>
+          <a:bodyPr wrap="square" lIns="0" tIns="0" rIns="0" bIns="0" rtlCol="0" anchor="ctr"/>
+          <a:lstStyle/>
+          <a:p>
+            <a:pPr indent="0" marL="0">
+              <a:buNone/>
+            </a:pPr>
+            <a:r>
+              <a:rPr lang="en-US" sz="1900" dirty="0">
                 <a:solidFill>
                   <a:srgbClr val="CADBD7"/>
                 </a:solidFill>
               </a:rPr>
               <a:t>Satu pipeline dari akuisisi data sampai model: augmentasi, imbalance, ensemble, dan reinforcement learning</a:t>
             </a:r>
-            <a:endParaRPr lang="en-US" sz="2000" dirty="0"/>
+            <a:endParaRPr lang="en-US" sz="1900" dirty="0"/>
           </a:p>
         </p:txBody>
       </p:sp>
@@ -2377,7 +2411,7 @@
         </p:nvSpPr>
         <p:spPr>
           <a:xfrm>
-            <a:off x="548640" y="4343400"/>
+            <a:off x="548640" y="4526280"/>
             <a:ext cx="7315200" cy="1097280"/>
           </a:xfrm>
           <a:prstGeom prst="rect">
@@ -2574,7 +2608,7 @@
           <a:bodyPr wrap="square" lIns="0" tIns="0" rIns="0" bIns="0" rtlCol="0" anchor="ctr"/>
           <a:lstStyle/>
           <a:p>
-            <a:pPr indent="0" marL="0">
+            <a:pPr algn="l" indent="0" marL="0">
               <a:buNone/>
             </a:pPr>
             <a:r>
@@ -2949,7 +2983,7 @@
                 <a:ea typeface="Cambria" pitchFamily="34" charset="-122"/>
                 <a:cs typeface="Cambria" pitchFamily="34" charset="-120"/>
               </a:rPr>
-              <a:t>0,88</a:t>
+              <a:t>acak 0,88</a:t>
             </a:r>
             <a:endParaRPr lang="en-US" sz="3000" dirty="0"/>
           </a:p>
@@ -3161,7 +3195,7 @@
           <a:bodyPr wrap="square" lIns="0" tIns="0" rIns="0" bIns="0" rtlCol="0" anchor="ctr"/>
           <a:lstStyle/>
           <a:p>
-            <a:pPr indent="0" marL="0">
+            <a:pPr algn="l" indent="0" marL="0">
               <a:buNone/>
             </a:pPr>
             <a:r>
@@ -3323,7 +3357,7 @@
           <a:ln/>
         </p:spPr>
         <p:txBody>
-          <a:bodyPr wrap="square" lIns="0" tIns="0" rIns="0" bIns="0" rtlCol="0" anchor="ctr"/>
+          <a:bodyPr wrap="square" lIns="0" tIns="0" rIns="0" bIns="0" rtlCol="0" anchor="t"/>
           <a:lstStyle/>
           <a:p>
             <a:pPr marL="342900" indent="-342900">
@@ -3462,7 +3496,7 @@
           <a:ln/>
         </p:spPr>
         <p:txBody>
-          <a:bodyPr wrap="square" lIns="0" tIns="0" rIns="0" bIns="0" rtlCol="0" anchor="ctr"/>
+          <a:bodyPr wrap="square" lIns="0" tIns="0" rIns="0" bIns="0" rtlCol="0" anchor="t"/>
           <a:lstStyle/>
           <a:p>
             <a:pPr marL="342900" indent="-342900">
@@ -3601,7 +3635,7 @@
           <a:ln/>
         </p:spPr>
         <p:txBody>
-          <a:bodyPr wrap="square" lIns="0" tIns="0" rIns="0" bIns="0" rtlCol="0" anchor="ctr"/>
+          <a:bodyPr wrap="square" lIns="0" tIns="0" rIns="0" bIns="0" rtlCol="0" anchor="t"/>
           <a:lstStyle/>
           <a:p>
             <a:pPr marL="342900" indent="-342900">
@@ -3740,7 +3774,7 @@
           <a:ln/>
         </p:spPr>
         <p:txBody>
-          <a:bodyPr wrap="square" lIns="0" tIns="0" rIns="0" bIns="0" rtlCol="0" anchor="ctr"/>
+          <a:bodyPr wrap="square" lIns="0" tIns="0" rIns="0" bIns="0" rtlCol="0" anchor="t"/>
           <a:lstStyle/>
           <a:p>
             <a:pPr marL="342900" indent="-342900">
@@ -3980,7 +4014,7 @@
         <p:spPr>
           <a:xfrm>
             <a:off x="1325880" y="1691640"/>
-            <a:ext cx="6675120" cy="411480"/>
+            <a:ext cx="6400800" cy="411480"/>
           </a:xfrm>
           <a:prstGeom prst="rect">
             <a:avLst/>
@@ -4016,7 +4050,7 @@
         <p:spPr>
           <a:xfrm>
             <a:off x="1325880" y="2103120"/>
-            <a:ext cx="6675120" cy="365760"/>
+            <a:ext cx="6400800" cy="365760"/>
           </a:xfrm>
           <a:prstGeom prst="rect">
             <a:avLst/>
@@ -4113,7 +4147,7 @@
         <p:spPr>
           <a:xfrm>
             <a:off x="1325880" y="2697480"/>
-            <a:ext cx="6675120" cy="411480"/>
+            <a:ext cx="6400800" cy="411480"/>
           </a:xfrm>
           <a:prstGeom prst="rect">
             <a:avLst/>
@@ -4149,7 +4183,7 @@
         <p:spPr>
           <a:xfrm>
             <a:off x="1325880" y="3108960"/>
-            <a:ext cx="6675120" cy="365760"/>
+            <a:ext cx="6400800" cy="365760"/>
           </a:xfrm>
           <a:prstGeom prst="rect">
             <a:avLst/>
@@ -4246,7 +4280,7 @@
         <p:spPr>
           <a:xfrm>
             <a:off x="1325880" y="3703320"/>
-            <a:ext cx="6675120" cy="411480"/>
+            <a:ext cx="6400800" cy="411480"/>
           </a:xfrm>
           <a:prstGeom prst="rect">
             <a:avLst/>
@@ -4282,7 +4316,7 @@
         <p:spPr>
           <a:xfrm>
             <a:off x="1325880" y="4114800"/>
-            <a:ext cx="6675120" cy="365760"/>
+            <a:ext cx="6400800" cy="365760"/>
           </a:xfrm>
           <a:prstGeom prst="rect">
             <a:avLst/>
@@ -4379,7 +4413,7 @@
         <p:spPr>
           <a:xfrm>
             <a:off x="1325880" y="4709160"/>
-            <a:ext cx="6675120" cy="411480"/>
+            <a:ext cx="6400800" cy="411480"/>
           </a:xfrm>
           <a:prstGeom prst="rect">
             <a:avLst/>
@@ -4415,7 +4449,7 @@
         <p:spPr>
           <a:xfrm>
             <a:off x="1325880" y="5120640"/>
-            <a:ext cx="6675120" cy="365760"/>
+            <a:ext cx="6400800" cy="365760"/>
           </a:xfrm>
           <a:prstGeom prst="rect">
             <a:avLst/>
@@ -4450,12 +4484,12 @@
         </p:nvSpPr>
         <p:spPr>
           <a:xfrm>
-            <a:off x="8183880" y="1691640"/>
-            <a:ext cx="3459175" cy="3886200"/>
+            <a:off x="7863840" y="1691640"/>
+            <a:ext cx="3779215" cy="3886200"/>
           </a:xfrm>
           <a:prstGeom prst="roundRect">
             <a:avLst>
-              <a:gd name="adj" fmla="val 3172"/>
+              <a:gd name="adj" fmla="val 2903"/>
             </a:avLst>
           </a:prstGeom>
           <a:solidFill>
@@ -4477,8 +4511,8 @@
         </p:nvSpPr>
         <p:spPr>
           <a:xfrm>
-            <a:off x="8412480" y="1920240"/>
-            <a:ext cx="3001975" cy="3474720"/>
+            <a:off x="8138160" y="1920240"/>
+            <a:ext cx="3230575" cy="3474720"/>
           </a:xfrm>
           <a:prstGeom prst="rect">
             <a:avLst/>
@@ -4492,12 +4526,12 @@
           <a:p>
             <a:pPr indent="0" marL="0">
               <a:spcAft>
-                <a:spcPts val="600"/>
+                <a:spcPts val="400"/>
               </a:spcAft>
               <a:buNone/>
             </a:pPr>
             <a:r>
-              <a:rPr lang="en-US" sz="2600" b="1" dirty="0">
+              <a:rPr lang="en-US" sz="2800" b="1" dirty="0">
                 <a:solidFill>
                   <a:schemeClr val="accent2"/>
                 </a:solidFill>
@@ -4507,12 +4541,12 @@
               </a:rPr>
               <a:t>Terima kasih</a:t>
             </a:r>
-            <a:endParaRPr lang="en-US" sz="1400" dirty="0"/>
+            <a:endParaRPr lang="en-US" sz="1300" dirty="0"/>
           </a:p>
           <a:p>
             <a:pPr indent="0" marL="0">
               <a:spcAft>
-                <a:spcPts val="600"/>
+                <a:spcPts val="400"/>
               </a:spcAft>
               <a:buNone/>
             </a:pPr>
@@ -4524,41 +4558,109 @@
               </a:rPr>
               <a:t> </a:t>
             </a:r>
-            <a:endParaRPr lang="en-US" sz="1400" dirty="0"/>
+            <a:endParaRPr lang="en-US" sz="1300" dirty="0"/>
           </a:p>
           <a:p>
             <a:pPr indent="0" marL="0">
               <a:spcAft>
-                <a:spcPts val="600"/>
+                <a:spcPts val="400"/>
               </a:spcAft>
               <a:buNone/>
             </a:pPr>
             <a:r>
-              <a:rPr lang="en-US" sz="1400" dirty="0">
+              <a:rPr lang="en-US" sz="1300" dirty="0">
                 <a:solidFill>
                   <a:srgbClr val="CADBD7"/>
                 </a:solidFill>
               </a:rPr>
-              <a:t>Kode &amp; notebook Colab:</a:t>
-            </a:r>
-            <a:endParaRPr lang="en-US" sz="1400" dirty="0"/>
+              <a:t>Kode (GitHub):</a:t>
+            </a:r>
+            <a:endParaRPr lang="en-US" sz="1300" dirty="0"/>
           </a:p>
           <a:p>
             <a:pPr indent="0" marL="0">
               <a:spcAft>
-                <a:spcPts val="600"/>
+                <a:spcPts val="400"/>
               </a:spcAft>
               <a:buNone/>
             </a:pPr>
             <a:r>
-              <a:rPr lang="en-US" sz="1400" b="1" dirty="0">
+              <a:rPr lang="en-US" sz="1300" b="1" dirty="0">
                 <a:solidFill>
                   <a:schemeClr val="bg1"/>
                 </a:solidFill>
               </a:rPr>
-              <a:t>github.com/MuhammadErlanggaKurniawan/ets-ml2-kelompok</a:t>
-            </a:r>
-            <a:endParaRPr lang="en-US" sz="1400" dirty="0"/>
+              <a:t>github.com/MuhammadErlanggaKurniawan</a:t>
+            </a:r>
+            <a:endParaRPr lang="en-US" sz="1300" dirty="0"/>
+          </a:p>
+          <a:p>
+            <a:pPr indent="0" marL="0">
+              <a:spcAft>
+                <a:spcPts val="400"/>
+              </a:spcAft>
+              <a:buNone/>
+            </a:pPr>
+            <a:r>
+              <a:rPr lang="en-US" sz="1300" b="1" dirty="0">
+                <a:solidFill>
+                  <a:schemeClr val="bg1"/>
+                </a:solidFill>
+              </a:rPr>
+              <a:t>/ets-ml2-kelompok</a:t>
+            </a:r>
+            <a:endParaRPr lang="en-US" sz="1300" dirty="0"/>
+          </a:p>
+          <a:p>
+            <a:pPr indent="0" marL="0">
+              <a:spcAft>
+                <a:spcPts val="400"/>
+              </a:spcAft>
+              <a:buNone/>
+            </a:pPr>
+            <a:r>
+              <a:rPr lang="en-US" sz="800" dirty="0">
+                <a:solidFill>
+                  <a:schemeClr val="bg1"/>
+                </a:solidFill>
+              </a:rPr>
+              <a:t> </a:t>
+            </a:r>
+            <a:endParaRPr lang="en-US" sz="1300" dirty="0"/>
+          </a:p>
+          <a:p>
+            <a:pPr indent="0" marL="0">
+              <a:spcAft>
+                <a:spcPts val="400"/>
+              </a:spcAft>
+              <a:buNone/>
+            </a:pPr>
+            <a:r>
+              <a:rPr lang="en-US" sz="1300" dirty="0">
+                <a:solidFill>
+                  <a:srgbClr val="CADBD7"/>
+                </a:solidFill>
+              </a:rPr>
+              <a:t>Notebook Colab (13 bagian):</a:t>
+            </a:r>
+            <a:endParaRPr lang="en-US" sz="1300" dirty="0"/>
+          </a:p>
+          <a:p>
+            <a:pPr indent="0" marL="0">
+              <a:spcAft>
+                <a:spcPts val="400"/>
+              </a:spcAft>
+              <a:buNone/>
+            </a:pPr>
+            <a:r>
+              <a:rPr lang="en-US" sz="1300" b="1" dirty="0">
+                <a:solidFill>
+                  <a:schemeClr val="bg1"/>
+                </a:solidFill>
+              </a:rPr>
+              <a:t>ETS_ML2_Pipeline_Lengkap.ipynb</a:t>
+            </a:r>
+            <a:endParaRPr lang="en-US" sz="1300" dirty="0"/>
           </a:p>
         </p:txBody>
       </p:sp>
@@ -4658,7 +4760,7 @@
           <a:bodyPr wrap="square" lIns="0" tIns="0" rIns="0" bIns="0" rtlCol="0" anchor="ctr"/>
           <a:lstStyle/>
           <a:p>
-            <a:pPr indent="0" marL="0">
+            <a:pPr algn="l" indent="0" marL="0">
               <a:buNone/>
             </a:pPr>
             <a:r>
@@ -4964,7 +5066,7 @@
           <a:bodyPr wrap="square" lIns="0" tIns="0" rIns="0" bIns="0" rtlCol="0" anchor="ctr"/>
           <a:lstStyle/>
           <a:p>
-            <a:pPr indent="0" marL="0">
+            <a:pPr algn="l" indent="0" marL="0">
               <a:buNone/>
             </a:pPr>
             <a:r>
@@ -5953,7 +6055,7 @@
           <a:bodyPr wrap="square" lIns="0" tIns="0" rIns="0" bIns="0" rtlCol="0" anchor="ctr"/>
           <a:lstStyle/>
           <a:p>
-            <a:pPr indent="0" marL="0">
+            <a:pPr algn="l" indent="0" marL="0">
               <a:buNone/>
             </a:pPr>
             <a:r>
@@ -7567,7 +7669,7 @@
           <a:bodyPr wrap="square" lIns="0" tIns="0" rIns="0" bIns="0" rtlCol="0" anchor="ctr"/>
           <a:lstStyle/>
           <a:p>
-            <a:pPr indent="0" marL="0">
+            <a:pPr algn="l" indent="0" marL="0">
               <a:buNone/>
             </a:pPr>
             <a:r>
@@ -8742,7 +8844,7 @@
           <a:bodyPr wrap="square" lIns="0" tIns="0" rIns="0" bIns="0" rtlCol="0" anchor="ctr"/>
           <a:lstStyle/>
           <a:p>
-            <a:pPr indent="0" marL="0">
+            <a:pPr algn="l" indent="0" marL="0">
               <a:buNone/>
             </a:pPr>
             <a:r>
@@ -9610,7 +9712,7 @@
           <a:bodyPr wrap="square" lIns="0" tIns="0" rIns="0" bIns="0" rtlCol="0" anchor="ctr"/>
           <a:lstStyle/>
           <a:p>
-            <a:pPr indent="0" marL="0">
+            <a:pPr algn="l" indent="0" marL="0">
               <a:buNone/>
             </a:pPr>
             <a:r>
@@ -10093,7 +10195,7 @@
           <a:bodyPr wrap="square" lIns="0" tIns="0" rIns="0" bIns="0" rtlCol="0" anchor="ctr"/>
           <a:lstStyle/>
           <a:p>
-            <a:pPr indent="0" marL="0">
+            <a:pPr algn="l" indent="0" marL="0">
               <a:buNone/>
             </a:pPr>
             <a:r>
@@ -10183,7 +10285,7 @@
         <p:spPr>
           <a:xfrm>
             <a:off x="548640" y="1188720"/>
-            <a:ext cx="11094415" cy="457200"/>
+            <a:ext cx="11094415" cy="365760"/>
           </a:xfrm>
           <a:prstGeom prst="rect">
             <a:avLst/>
@@ -10204,7 +10306,7 @@
                   <a:schemeClr val="tx1"/>
                 </a:solidFill>
               </a:rPr>
-              <a:t>Ensemble = menggabungkan banyak model.  </a:t>
+              <a:t>Ensemble = gabungan banyak model:  </a:t>
             </a:r>
             <a:pPr indent="0" marL="0">
               <a:buNone/>
@@ -10215,7 +10317,7 @@
                   <a:schemeClr val="tx1"/>
                 </a:solidFill>
               </a:rPr>
-              <a:t>Bagging: Random Forest  ·  Boosting: XGBoost, LightGBM  ·  Stacking: satu model menggabungkan prediksi model lain</a:t>
+              <a:t>Random Forest (bagging) · XGBoost, LightGBM (boosting) · Stacking (model penggabung)</a:t>
             </a:r>
             <a:endParaRPr lang="en-US" sz="1500" dirty="0"/>
           </a:p>
@@ -10237,8 +10339,8 @@
         </p:blipFill>
         <p:spPr>
           <a:xfrm>
-            <a:off x="1026100" y="1691640"/>
-            <a:ext cx="4441412" cy="3520440"/>
+            <a:off x="997259" y="1645920"/>
+            <a:ext cx="4499093" cy="3566160"/>
           </a:xfrm>
           <a:prstGeom prst="rect">
             <a:avLst/>
@@ -10261,7 +10363,7 @@
         </p:blipFill>
         <p:spPr>
           <a:xfrm>
-            <a:off x="6246724" y="1889185"/>
+            <a:off x="6246724" y="1866325"/>
             <a:ext cx="5396332" cy="3125349"/>
           </a:xfrm>
           <a:prstGeom prst="rect">
@@ -10513,7 +10615,7 @@
           <a:bodyPr wrap="square" lIns="0" tIns="0" rIns="0" bIns="0" rtlCol="0" anchor="ctr"/>
           <a:lstStyle/>
           <a:p>
-            <a:pPr indent="0" marL="0">
+            <a:pPr algn="l" indent="0" marL="0">
               <a:buNone/>
             </a:pPr>
             <a:r>
@@ -10822,7 +10924,7 @@
           <a:bodyPr wrap="square" lIns="0" tIns="0" rIns="0" bIns="0" rtlCol="0" anchor="ctr"/>
           <a:lstStyle/>
           <a:p>
-            <a:pPr indent="0" marL="0">
+            <a:pPr algn="l" indent="0" marL="0">
               <a:buNone/>
             </a:pPr>
             <a:r>
@@ -11514,8 +11616,8 @@
         </p:blipFill>
         <p:spPr>
           <a:xfrm>
-            <a:off x="5472330" y="1234440"/>
-            <a:ext cx="6093355" cy="4069080"/>
+            <a:off x="5591405" y="1234440"/>
+            <a:ext cx="5855205" cy="4069080"/>
           </a:xfrm>
           <a:prstGeom prst="rect">
             <a:avLst/>

</xml_diff>